<commit_message>
Refine PVC literature takeaway
</commit_message>
<xml_diff>
--- a/presentations/pvc-aq/PVC_Literature_Project_Vertical.pptx
+++ b/presentations/pvc-aq/PVC_Literature_Project_Vertical.pptx
@@ -502,7 +502,7 @@
           <a:lstStyle/>
           <a:p>
             <a:r>
-              <a:t>左侧保留Gardette等1989年Macromolecules论文印刷页2580的原始机制图，避免重绘造成结构或箭头误差。原图中的波数属于该文献的产物归属，并非此前删除的用户PVC红外数据。右侧将文献启发转化为本课题自上而下的三步验证路径：第一步用光暗、有无EAQ及DCE空白核实光敏增益并排除溶剂自身反应；第二步结合EPR、自由基捕获和气氛对照识别Cl自由基及氧相关物种的贡献；第三步通过氯平衡、产物分析与SEC/GPC链长变化，区分脱氯、氧化和真正的主链断裂。该路径不预设Cl自由基已经被证明，也不把官能团变化直接等同于聚合物降解。页底结论用于衔接下一页：随后进一步说明为何选用EAQ作为候选光敏入口。</a:t>
+              <a:t>左侧保留Gardette等1989年Macromolecules论文印刷页2580的原始机制图，避免重绘造成结构或箭头误差。原图中的波数属于该文献的产物归属，并非此前删除的用户PVC红外数据。Gardette论文的直接工作是解析PVC光氧化老化机理；这一研究方向总体服务于材料耐久性与稳定化认识，因此讲解时可表述为“早期研究希望理解并抑制老化”，不宜把该论文直接说成稳定剂设计研究。右侧将文献启发转化为本课题自上而下的三步验证路径：第一步用光暗、有无EAQ及DCE空白核实光敏增益并排除溶剂自身反应；第二步结合EPR、自由基捕获和气氛对照识别Cl自由基及氧相关物种的贡献；第三步通过氯平衡、产物分析与SEC/GPC链长变化，区分脱氯、氧化和真正的主链断裂。该路径不预设Cl自由基已经被证明，也不把官能团变化直接等同于聚合物降解。建议下一页先介绍二氯甲烷中氯自由基促进PS光裂解的最新文献，证明“含氯介质—氯自由基—聚合物断裂”具有文献先例；之后再引出EAQ作为本课题调节反应入口的候选光敏剂。</a:t>
             </a:r>
           </a:p>
         </p:txBody>
@@ -5386,7 +5386,7 @@
               <a:spcAft>
                 <a:spcPts val="600"/>
               </a:spcAft>
-              <a:defRPr sz="1550" b="1">
+              <a:defRPr sz="1320" b="1">
                 <a:solidFill>
                   <a:srgbClr val="C00000"/>
                 </a:solidFill>
@@ -5394,7 +5394,7 @@
               </a:defRPr>
             </a:pPr>
             <a:r>
-              <a:t>以对照实验锁定光敏入口与活性物种，再用氯平衡、产物和链长变化确认 PVC 是否发生真实断链。</a:t>
+              <a:t>早期研究为理解并抑制 PVC 光老化而解析自由基氧化与断链；本课题反向利用这一失效路径，探索光敏诱导的可控降解。</a:t>
             </a:r>
           </a:p>
         </p:txBody>

</xml_diff>